<commit_message>
Add CMPB Update submission documents (EN/JA docx, cover letter, declarations)
- yoshika_CMPB_Update_EN.docx: English manuscript with inline figures
- yoshika_CMPB_Update_JA.docx: Japanese manuscript for author review
- cover_letter_CMPB_Update.docx: Cover letter
- highlights.docx: Highlights (5 items)
- declaration_of_interest.docx: COI declaration
- author_statement_CRediT.docx: CRediT authorship statement
- data_availability.docx: Data availability statement
- Updated figures PPTX
- Removed old single-language manuscript file

Co-Authored-By: Tatsuki Onishi <bougtoir@gmail.com>
</commit_message>
<xml_diff>
--- a/v1/output/yoshika_CMPB_Update_figures.pptx
+++ b/v1/output/yoshika_CMPB_Update_figures.pptx
@@ -3278,7 +3278,7 @@
               <a:defRPr sz="1400"/>
             </a:pPr>
             <a:r>
-              <a:t>Figure 2. Bupivacaine 150 mg -- Plasma concentration by initial compartment with toxicity thresholds.</a:t>
+              <a:t>Figure 2. Bupivacaine 150 mg — Plasma concentration by initial compartment with toxicity thresholds.</a:t>
             </a:r>
           </a:p>
         </p:txBody>
@@ -3348,8 +3348,8 @@
         </p:blipFill>
         <p:spPr>
           <a:xfrm>
-            <a:off x="2996552" y="914400"/>
-            <a:ext cx="6198591" cy="4572000"/>
+            <a:off x="4268481" y="914400"/>
+            <a:ext cx="3654733" cy="4572000"/>
           </a:xfrm>
           <a:prstGeom prst="rect">
             <a:avLst/>
@@ -3486,7 +3486,7 @@
               <a:defRPr sz="1400"/>
             </a:pPr>
             <a:r>
-              <a:t>Figure 4. Bupivacaine -- Effect-site response by initial compartment.</a:t>
+              <a:t>Figure 4. Bupivacaine — Effect-site response by initial compartment.</a:t>
             </a:r>
           </a:p>
         </p:txBody>
@@ -3556,8 +3556,8 @@
         </p:blipFill>
         <p:spPr>
           <a:xfrm>
-            <a:off x="2148510" y="914400"/>
-            <a:ext cx="7894674" cy="4572000"/>
+            <a:off x="2254745" y="914400"/>
+            <a:ext cx="7682204" cy="4572000"/>
           </a:xfrm>
           <a:prstGeom prst="rect">
             <a:avLst/>
@@ -3590,7 +3590,7 @@
               <a:defRPr sz="1400"/>
             </a:pPr>
             <a:r>
-              <a:t>Figure 5. Bupivacaine 150 mg from BPT -- Full compartment concentration profile.</a:t>
+              <a:t>Figure 5. Bupivacaine 150 mg from BPT — Full compartment concentration profile.</a:t>
             </a:r>
           </a:p>
         </p:txBody>
@@ -3661,7 +3661,7 @@
         <p:spPr>
           <a:xfrm>
             <a:off x="1066647" y="914400"/>
-            <a:ext cx="10058400" cy="2163641"/>
+            <a:ext cx="10058400" cy="2426637"/>
           </a:xfrm>
           <a:prstGeom prst="rect">
             <a:avLst/>
@@ -3694,7 +3694,7 @@
               <a:defRPr sz="1400"/>
             </a:pPr>
             <a:r>
-              <a:t>Figure 6. Bupivacaine 150 mg -- PK/PD summary by initial compartment.</a:t>
+              <a:t>Figure 6. Bupivacaine 150 mg — PK/PD summary by initial compartment.</a:t>
             </a:r>
           </a:p>
         </p:txBody>

</xml_diff>